<commit_message>
Update Parallel Thinking slides and clean up gitignore
Co-Authored-By: Claude Opus 4.6 (1M context) <noreply@anthropic.com>
</commit_message>
<xml_diff>
--- a/slides/Parallel_Thinking_3.pptx
+++ b/slides/Parallel_Thinking_3.pptx
@@ -2098,7 +2098,7 @@
                 <a:ea typeface="Calibri" pitchFamily="34" charset="-122"/>
                 <a:cs typeface="Calibri" pitchFamily="34" charset="-120"/>
               </a:rPr>
-              <a:t>How a 1985 Boston startup named Thinking Machines invented the architecture that led to modern day AI data centers</a:t>
+              <a:t>How a 1983 Boston startup named Thinking Machines invented the architecture that led to modern day AI data centers</a:t>
             </a:r>
             <a:endParaRPr lang="en-US" sz="1400" dirty="0"/>
           </a:p>
@@ -2276,7 +2276,7 @@
                 <a:ea typeface="Georgia" pitchFamily="34" charset="-122"/>
                 <a:cs typeface="Georgia" pitchFamily="34" charset="-120"/>
               </a:rPr>
-              <a:t>1985</a:t>
+              <a:t>1983</a:t>
             </a:r>
             <a:endParaRPr lang="en-US" sz="4800" dirty="0"/>
           </a:p>

</xml_diff>